<commit_message>
add results, extend comparator, some fixes
</commit_message>
<xml_diff>
--- a/presentation/RBST_prompt-eng [Autosaved].pptx
+++ b/presentation/RBST_prompt-eng [Autosaved].pptx
@@ -206,7 +206,7 @@
           <a:p>
             <a:fld id="{0C1CC868-F01F-4D3C-B0FF-9A3075033AE5}" type="datetimeFigureOut">
               <a:rPr lang="en-AT" smtClean="0"/>
-              <a:t>23/04/2025</a:t>
+              <a:t>29/04/2025</a:t>
             </a:fld>
             <a:endParaRPr lang="en-AT"/>
           </a:p>
@@ -518,140 +518,7 @@
           <a:bodyPr/>
           <a:lstStyle/>
           <a:p>
-            <a:r>
-              <a:rPr lang="en-GB" dirty="0"/>
-              <a:t>Quick refresher of software testing.</a:t>
-            </a:r>
-          </a:p>
-          <a:p>
-            <a:pPr marL="171450" indent="-171450">
-              <a:buFontTx/>
-              <a:buChar char="-"/>
-            </a:pPr>
-            <a:r>
-              <a:rPr lang="en-GB" dirty="0"/>
-              <a:t>Needed to verify and validate developed software to meet specifications (describe picture)</a:t>
-            </a:r>
-          </a:p>
-          <a:p>
-            <a:pPr marL="171450" indent="-171450">
-              <a:buFontTx/>
-              <a:buChar char="-"/>
-            </a:pPr>
-            <a:r>
-              <a:rPr lang="en-GB" dirty="0"/>
-              <a:t>Prevent and find errors in a system</a:t>
-            </a:r>
-          </a:p>
-          <a:p>
-            <a:pPr marL="171450" indent="-171450">
-              <a:buFontTx/>
-              <a:buChar char="-"/>
-            </a:pPr>
-            <a:r>
-              <a:rPr lang="en-GB" dirty="0"/>
-              <a:t>Analyze for usability, compatibility, reliability, integrity, efficiency, security, portability, maintainability, …</a:t>
-            </a:r>
-          </a:p>
-          <a:p>
-            <a:endParaRPr lang="en-GB" dirty="0"/>
-          </a:p>
-          <a:p>
-            <a:r>
-              <a:rPr lang="en-GB" dirty="0"/>
-              <a:t>In general there are four types of testing strategies.</a:t>
-            </a:r>
-          </a:p>
-          <a:p>
-            <a:pPr marL="171450" indent="-171450">
-              <a:buFontTx/>
-              <a:buChar char="-"/>
-            </a:pPr>
-            <a:r>
-              <a:rPr lang="en-GB" dirty="0"/>
-              <a:t>Unit testing: smallest testable part (done by developer)</a:t>
-            </a:r>
-          </a:p>
-          <a:p>
-            <a:pPr marL="171450" indent="-171450">
-              <a:buFontTx/>
-              <a:buChar char="-"/>
-            </a:pPr>
-            <a:r>
-              <a:rPr lang="en-GB" dirty="0"/>
-              <a:t>Integration testing: integrate unit tested component and test them as a group – interfacing</a:t>
-            </a:r>
-          </a:p>
-          <a:p>
-            <a:pPr marL="171450" indent="-171450">
-              <a:buFontTx/>
-              <a:buChar char="-"/>
-            </a:pPr>
-            <a:r>
-              <a:rPr lang="en-GB" dirty="0"/>
-              <a:t>Acceptance/Validation testing: authenticate whether product is developed as per standards and detailed criteria and meets all requirements specified by the user</a:t>
-            </a:r>
-          </a:p>
-          <a:p>
-            <a:pPr marL="171450" indent="-171450">
-              <a:buFontTx/>
-              <a:buChar char="-"/>
-            </a:pPr>
-            <a:r>
-              <a:rPr lang="en-GB" dirty="0"/>
-              <a:t>System testing: testing done on complete integrated system</a:t>
-            </a:r>
-          </a:p>
-          <a:p>
-            <a:endParaRPr lang="en-GB" dirty="0"/>
-          </a:p>
-          <a:p>
-            <a:r>
-              <a:rPr lang="en-GB" dirty="0"/>
-              <a:t>This requires a lot of resources, human, costs, time … usually separate test team</a:t>
-            </a:r>
-          </a:p>
-          <a:p>
-            <a:r>
-              <a:rPr lang="en-GB" dirty="0"/>
-              <a:t>If you have experience many tests are pretty basic from a complexity perspective.</a:t>
-            </a:r>
-          </a:p>
-          <a:p>
-            <a:r>
-              <a:rPr lang="en-GB" dirty="0"/>
-              <a:t>Especially in the industry -&gt; fast development cycle for new products / projects are essential to stay competitive </a:t>
-            </a:r>
-          </a:p>
-          <a:p>
-            <a:endParaRPr lang="en-GB" dirty="0"/>
-          </a:p>
-          <a:p>
-            <a:r>
-              <a:rPr lang="en-GB" dirty="0"/>
-              <a:t>Recent years with upcoming powerful LLM’s there are now many possibilities to change the classic approach and potentially minimize or optimize testing efforts.</a:t>
-            </a:r>
-          </a:p>
-          <a:p>
-            <a:r>
-              <a:rPr lang="en-GB" dirty="0"/>
-              <a:t>Overview of areas of research where LLM’s are applied most:</a:t>
-            </a:r>
-          </a:p>
-          <a:p>
-            <a:endParaRPr lang="en-GB" dirty="0"/>
-          </a:p>
-          <a:p>
-            <a:r>
-              <a:rPr lang="en-GB" dirty="0"/>
-              <a:t>Large amount of research in recent years focuses mainly on utilizing LLM for automating unit test generation for high coverage. (-&gt; generating tests for code snippets)</a:t>
-            </a:r>
-          </a:p>
-          <a:p>
-            <a:r>
-              <a:rPr lang="en-GB" dirty="0"/>
-              <a:t>Generating test scenarios for system tests. </a:t>
-            </a:r>
+            <a:endParaRPr lang="en-AT" dirty="0"/>
           </a:p>
         </p:txBody>
       </p:sp>
@@ -672,7 +539,7 @@
           <a:p>
             <a:fld id="{75C8DF60-03EB-41BF-AD08-E11AFAEB47A5}" type="slidenum">
               <a:rPr lang="en-AT" smtClean="0"/>
-              <a:t>3</a:t>
+              <a:t>1</a:t>
             </a:fld>
             <a:endParaRPr lang="en-AT"/>
           </a:p>
@@ -681,7 +548,7 @@
     </p:spTree>
     <p:extLst>
       <p:ext uri="{BB962C8B-B14F-4D97-AF65-F5344CB8AC3E}">
-        <p14:creationId xmlns:p14="http://schemas.microsoft.com/office/powerpoint/2010/main" val="638221337"/>
+        <p14:creationId xmlns:p14="http://schemas.microsoft.com/office/powerpoint/2010/main" val="1322344735"/>
       </p:ext>
     </p:extLst>
   </p:cSld>
@@ -737,108 +604,7 @@
           <a:p>
             <a:r>
               <a:rPr lang="en-GB" dirty="0"/>
-              <a:t>I found little research trying to utilize directly the software requirements as a resource to generate testcases.</a:t>
-            </a:r>
-          </a:p>
-          <a:p>
-            <a:pPr marL="171450" indent="-171450">
-              <a:buFont typeface="Wingdings" panose="05000000000000000000" pitchFamily="2" charset="2"/>
-              <a:buChar char="è"/>
-            </a:pPr>
-            <a:r>
-              <a:rPr lang="en-GB" dirty="0"/>
-              <a:t>Falling more in the category of acceptance testing</a:t>
-            </a:r>
-            <a:br>
-              <a:rPr lang="en-GB" dirty="0"/>
-            </a:br>
-            <a:endParaRPr lang="en-GB" dirty="0"/>
-          </a:p>
-          <a:p>
-            <a:pPr marL="0" marR="0" lvl="0" indent="0" algn="l" defTabSz="914400" rtl="0" eaLnBrk="1" fontAlgn="auto" latinLnBrk="0" hangingPunct="1">
-              <a:lnSpc>
-                <a:spcPct val="100000"/>
-              </a:lnSpc>
-              <a:spcBef>
-                <a:spcPts val="0"/>
-              </a:spcBef>
-              <a:spcAft>
-                <a:spcPts val="0"/>
-              </a:spcAft>
-              <a:buClrTx/>
-              <a:buSzTx/>
-              <a:buFont typeface="Wingdings" panose="05000000000000000000" pitchFamily="2" charset="2"/>
-              <a:buNone/>
-              <a:tabLst/>
-              <a:defRPr/>
-            </a:pPr>
-            <a:r>
-              <a:rPr lang="en-GB" dirty="0"/>
-              <a:t>Especially when tests can be related to requirements this usually is a complete process (describe picture) to exactly track the process.</a:t>
-            </a:r>
-          </a:p>
-          <a:p>
-            <a:pPr marL="0" indent="0">
-              <a:buFont typeface="Wingdings" panose="05000000000000000000" pitchFamily="2" charset="2"/>
-              <a:buNone/>
-            </a:pPr>
-            <a:br>
-              <a:rPr lang="en-GB" dirty="0"/>
-            </a:br>
-            <a:r>
-              <a:rPr lang="en-GB" dirty="0"/>
-              <a:t>And generally </a:t>
-            </a:r>
-          </a:p>
-          <a:p>
-            <a:pPr marL="0" indent="0">
-              <a:buFont typeface="Wingdings" panose="05000000000000000000" pitchFamily="2" charset="2"/>
-              <a:buNone/>
-            </a:pPr>
-            <a:r>
-              <a:rPr lang="en-GB" dirty="0"/>
-              <a:t>- Management Defines Product Requirements in combination with Customers </a:t>
-            </a:r>
-          </a:p>
-          <a:p>
-            <a:r>
-              <a:rPr lang="en-GB" dirty="0"/>
-              <a:t>- Technical Leads derive Software Requirements</a:t>
-            </a:r>
-          </a:p>
-          <a:p>
-            <a:r>
-              <a:rPr lang="en-GB" dirty="0"/>
-              <a:t>- Separate test team:</a:t>
-            </a:r>
-          </a:p>
-          <a:p>
-            <a:pPr lvl="1"/>
-            <a:r>
-              <a:rPr lang="en-GB" dirty="0"/>
-              <a:t>Initial Tests are derived from Requirements</a:t>
-            </a:r>
-          </a:p>
-          <a:p>
-            <a:pPr lvl="1"/>
-            <a:r>
-              <a:rPr lang="en-GB" dirty="0"/>
-              <a:t>(later system tests)</a:t>
-            </a:r>
-          </a:p>
-          <a:p>
-            <a:endParaRPr lang="en-GB" dirty="0"/>
-          </a:p>
-          <a:p>
-            <a:r>
-              <a:rPr lang="en-GB" dirty="0"/>
-              <a:t>High confidence that requirements are met is required at an early stage. </a:t>
-            </a:r>
-          </a:p>
-          <a:p>
-            <a:r>
-              <a:rPr lang="en-GB" dirty="0"/>
-              <a:t>Biggest factor therefore are definitions of requirements </a:t>
+              <a:t>Quick refresher on software testing.</a:t>
             </a:r>
           </a:p>
           <a:p>
@@ -848,30 +614,7 @@
             </a:pPr>
             <a:r>
               <a:rPr lang="en-GB" dirty="0"/>
-              <a:t>how detailed requirements are defined – usually using natural language</a:t>
-            </a:r>
-          </a:p>
-          <a:p>
-            <a:pPr marL="171450" marR="0" lvl="0" indent="-171450" algn="l" defTabSz="914400" rtl="0" eaLnBrk="1" fontAlgn="auto" latinLnBrk="0" hangingPunct="1">
-              <a:lnSpc>
-                <a:spcPct val="100000"/>
-              </a:lnSpc>
-              <a:spcBef>
-                <a:spcPts val="0"/>
-              </a:spcBef>
-              <a:spcAft>
-                <a:spcPts val="0"/>
-              </a:spcAft>
-              <a:buClrTx/>
-              <a:buSzTx/>
-              <a:buFontTx/>
-              <a:buChar char="-"/>
-              <a:tabLst/>
-              <a:defRPr/>
-            </a:pPr>
-            <a:r>
-              <a:rPr lang="en-GB" dirty="0"/>
-              <a:t>room for interpretation – possible conflicts, … but definition is another topic (verifying requirements for completeness, integrity, …. Is another story)</a:t>
+              <a:t>Needed to verify and validate developed software to meet specifications </a:t>
             </a:r>
           </a:p>
           <a:p>
@@ -881,7 +624,16 @@
             </a:pPr>
             <a:r>
               <a:rPr lang="en-GB" dirty="0"/>
-              <a:t>requirements define what the system must to but not how.</a:t>
+              <a:t>Analyze for usability, compatibility, reliability, integrity, efficiency, security, portability, maintainability, …</a:t>
+            </a:r>
+          </a:p>
+          <a:p>
+            <a:endParaRPr lang="en-GB" dirty="0"/>
+          </a:p>
+          <a:p>
+            <a:r>
+              <a:rPr lang="en-GB" dirty="0"/>
+              <a:t>In general there are four types of testing strategies.</a:t>
             </a:r>
           </a:p>
           <a:p>
@@ -891,7 +643,37 @@
             </a:pPr>
             <a:r>
               <a:rPr lang="en-GB" dirty="0"/>
-              <a:t>basic functionality of a system shall be tested through simple testcases that relate to at least one requirement.</a:t>
+              <a:t>Unit testing: smallest testable part (done by developer)</a:t>
+            </a:r>
+          </a:p>
+          <a:p>
+            <a:pPr marL="171450" indent="-171450">
+              <a:buFontTx/>
+              <a:buChar char="-"/>
+            </a:pPr>
+            <a:r>
+              <a:rPr lang="en-GB" dirty="0"/>
+              <a:t>Integration testing: integrate unit tested component and test them as a group – interfacing</a:t>
+            </a:r>
+          </a:p>
+          <a:p>
+            <a:pPr marL="171450" indent="-171450">
+              <a:buFontTx/>
+              <a:buChar char="-"/>
+            </a:pPr>
+            <a:r>
+              <a:rPr lang="en-GB" dirty="0"/>
+              <a:t>Acceptance/Validation testing: authenticate whether product is developed as per standards and detailed criteria and meets all requirements specified by the user</a:t>
+            </a:r>
+          </a:p>
+          <a:p>
+            <a:pPr marL="171450" indent="-171450">
+              <a:buFontTx/>
+              <a:buChar char="-"/>
+            </a:pPr>
+            <a:r>
+              <a:rPr lang="en-GB" dirty="0"/>
+              <a:t>System testing: testing done on complete integrated system</a:t>
             </a:r>
           </a:p>
           <a:p>
@@ -900,25 +682,37 @@
           <a:p>
             <a:r>
               <a:rPr lang="en-GB" dirty="0"/>
-              <a:t>Requirements usually short precise definition of expected behaviour.</a:t>
-            </a:r>
+              <a:t>This requires a lot of resources, human, costs, time … -&gt; trade off between under and over testing</a:t>
+            </a:r>
+          </a:p>
+          <a:p>
+            <a:endParaRPr lang="en-GB" dirty="0"/>
           </a:p>
           <a:p>
             <a:r>
               <a:rPr lang="en-GB" dirty="0"/>
-              <a:t>I am interested in how capable LLM’s are in generating structured test case description out of natural language requirements.</a:t>
-            </a:r>
+              <a:t>Recent years with upcoming powerful LLM’s there are now possibilities to change the classic approach and potentially minimize or optimize testing efforts.</a:t>
+            </a:r>
+          </a:p>
+          <a:p>
+            <a:endParaRPr lang="en-GB" dirty="0"/>
           </a:p>
           <a:p>
             <a:r>
               <a:rPr lang="en-GB" dirty="0"/>
-              <a:t>Especially in techincal domains.</a:t>
+              <a:t>Large amount of research in recent years focuses mainly on utilizing LLM for automating unit test generation for high coverage. (-&gt; generating tests from code snippets)</a:t>
             </a:r>
           </a:p>
           <a:p>
             <a:r>
               <a:rPr lang="en-GB" dirty="0"/>
-              <a:t>Idea that in the future the approach would be a semi automatic acceptance testing pipeline with human in the loop.</a:t>
+              <a:t>And System tests -&gt; software already done for the most part. (mainly for GUI testing mobile apps)</a:t>
+            </a:r>
+          </a:p>
+          <a:p>
+            <a:r>
+              <a:rPr lang="en-GB" dirty="0"/>
+              <a:t>Generating test scenarios for the whole system.</a:t>
             </a:r>
           </a:p>
           <a:p>
@@ -927,33 +721,20 @@
           <a:p>
             <a:r>
               <a:rPr lang="en-GB" dirty="0"/>
-              <a:t>requirements -&gt; LLM -&gt; TC’s + Human verification -&gt; LLM -&gt; implementation + Human verification</a:t>
+              <a:t>Even projects which act as a whole development team (archcode) -&gt; given problem statement and system goes through the whole process of</a:t>
+            </a:r>
+          </a:p>
+          <a:p>
+            <a:r>
+              <a:rPr lang="en-GB" dirty="0"/>
+              <a:t>Defining requirements, creating testcases and implementation.</a:t>
             </a:r>
           </a:p>
           <a:p>
             <a:endParaRPr lang="en-GB" dirty="0"/>
           </a:p>
           <a:p>
-            <a:r>
-              <a:rPr lang="en-GB" dirty="0"/>
-              <a:t>First we need to get an impression of how capable the models are to understand the requirements.</a:t>
-            </a:r>
-            <a:endParaRPr lang="en-AT" dirty="0"/>
-          </a:p>
-          <a:p>
             <a:endParaRPr lang="en-GB" dirty="0"/>
-          </a:p>
-          <a:p>
-            <a:endParaRPr lang="en-GB" dirty="0"/>
-          </a:p>
-          <a:p>
-            <a:pPr marL="0" indent="0">
-              <a:buNone/>
-            </a:pPr>
-            <a:endParaRPr lang="en-GB" dirty="0"/>
-          </a:p>
-          <a:p>
-            <a:endParaRPr lang="en-AT" dirty="0"/>
           </a:p>
         </p:txBody>
       </p:sp>
@@ -974,7 +755,7 @@
           <a:p>
             <a:fld id="{75C8DF60-03EB-41BF-AD08-E11AFAEB47A5}" type="slidenum">
               <a:rPr lang="en-AT" smtClean="0"/>
-              <a:t>4</a:t>
+              <a:t>3</a:t>
             </a:fld>
             <a:endParaRPr lang="en-AT"/>
           </a:p>
@@ -983,7 +764,7 @@
     </p:spTree>
     <p:extLst>
       <p:ext uri="{BB962C8B-B14F-4D97-AF65-F5344CB8AC3E}">
-        <p14:creationId xmlns:p14="http://schemas.microsoft.com/office/powerpoint/2010/main" val="3541748672"/>
+        <p14:creationId xmlns:p14="http://schemas.microsoft.com/office/powerpoint/2010/main" val="638221337"/>
       </p:ext>
     </p:extLst>
   </p:cSld>
@@ -1037,298 +818,56 @@
           <a:bodyPr/>
           <a:lstStyle/>
           <a:p>
-            <a:pPr marL="0" marR="0" lvl="0" indent="0" algn="l" defTabSz="914400" rtl="0" eaLnBrk="1" fontAlgn="auto" latinLnBrk="0" hangingPunct="1">
-              <a:lnSpc>
-                <a:spcPct val="100000"/>
-              </a:lnSpc>
-              <a:spcBef>
-                <a:spcPts val="0"/>
-              </a:spcBef>
-              <a:spcAft>
-                <a:spcPts val="0"/>
-              </a:spcAft>
-              <a:buClrTx/>
-              <a:buSzTx/>
+            <a:r>
+              <a:rPr lang="en-GB" dirty="0"/>
+              <a:t>What I am interested in and where I also found little research is trying to utilize the software requirements as a resource to generate testcases.</a:t>
+            </a:r>
+          </a:p>
+          <a:p>
+            <a:r>
+              <a:rPr lang="en-GB" dirty="0"/>
+              <a:t>As in industrial settings integrating LLM’s in the development processes will be a step by step process.</a:t>
+            </a:r>
+          </a:p>
+          <a:p>
+            <a:r>
+              <a:rPr lang="en-GB" dirty="0"/>
+              <a:t>Since for unit testing they are already commonly used, I wanted to approach the topic from the other direction starting at the requirements.</a:t>
+            </a:r>
+          </a:p>
+          <a:p>
+            <a:pPr marL="171450" indent="-171450">
+              <a:buFont typeface="Wingdings" panose="05000000000000000000" pitchFamily="2" charset="2"/>
+              <a:buChar char="è"/>
+            </a:pPr>
+            <a:r>
+              <a:rPr lang="en-GB" dirty="0"/>
+              <a:t> acceptance testing</a:t>
+            </a:r>
+          </a:p>
+          <a:p>
+            <a:endParaRPr lang="en-GB" dirty="0"/>
+          </a:p>
+          <a:p>
+            <a:r>
+              <a:rPr lang="en-GB" dirty="0"/>
+              <a:t>High confidence that requirements are met is required at an early stage of developement. </a:t>
+            </a:r>
+          </a:p>
+          <a:p>
+            <a:r>
+              <a:rPr lang="en-GB" dirty="0"/>
+              <a:t>Biggest factor therefore are definitions of requirements </a:t>
+            </a:r>
+          </a:p>
+          <a:p>
+            <a:pPr marL="171450" indent="-171450">
               <a:buFontTx/>
-              <a:buNone/>
-              <a:tabLst/>
-              <a:defRPr/>
+              <a:buChar char="-"/>
             </a:pPr>
             <a:r>
               <a:rPr lang="en-GB" dirty="0"/>
-              <a:t>As an experimental setup I created a framework for structured test descriptions.</a:t>
-            </a:r>
-          </a:p>
-          <a:p>
-            <a:pPr marL="0" marR="0" lvl="0" indent="0" algn="l" defTabSz="914400" rtl="0" eaLnBrk="1" fontAlgn="auto" latinLnBrk="0" hangingPunct="1">
-              <a:lnSpc>
-                <a:spcPct val="100000"/>
-              </a:lnSpc>
-              <a:spcBef>
-                <a:spcPts val="0"/>
-              </a:spcBef>
-              <a:spcAft>
-                <a:spcPts val="0"/>
-              </a:spcAft>
-              <a:buClrTx/>
-              <a:buSzTx/>
-              <a:buFontTx/>
-              <a:buNone/>
-              <a:tabLst/>
-              <a:defRPr/>
-            </a:pPr>
-            <a:r>
-              <a:rPr lang="en-GB" dirty="0"/>
-              <a:t>As the difficulty is not to generate output, but to evaluate the quality of the output</a:t>
-            </a:r>
-          </a:p>
-          <a:p>
-            <a:pPr marL="0" marR="0" lvl="0" indent="0" algn="l" defTabSz="914400" rtl="0" eaLnBrk="1" fontAlgn="auto" latinLnBrk="0" hangingPunct="1">
-              <a:lnSpc>
-                <a:spcPct val="100000"/>
-              </a:lnSpc>
-              <a:spcBef>
-                <a:spcPts val="0"/>
-              </a:spcBef>
-              <a:spcAft>
-                <a:spcPts val="0"/>
-              </a:spcAft>
-              <a:buClrTx/>
-              <a:buSzTx/>
-              <a:buFontTx/>
-              <a:buNone/>
-              <a:tabLst/>
-              <a:defRPr/>
-            </a:pPr>
-            <a:endParaRPr lang="en-GB" dirty="0"/>
-          </a:p>
-          <a:p>
-            <a:pPr marL="0" marR="0" lvl="0" indent="0" algn="l" defTabSz="914400" rtl="0" eaLnBrk="1" fontAlgn="auto" latinLnBrk="0" hangingPunct="1">
-              <a:lnSpc>
-                <a:spcPct val="100000"/>
-              </a:lnSpc>
-              <a:spcBef>
-                <a:spcPts val="0"/>
-              </a:spcBef>
-              <a:spcAft>
-                <a:spcPts val="0"/>
-              </a:spcAft>
-              <a:buClrTx/>
-              <a:buSzTx/>
-              <a:buFontTx/>
-              <a:buNone/>
-              <a:tabLst/>
-              <a:defRPr/>
-            </a:pPr>
-            <a:r>
-              <a:rPr lang="en-GB" dirty="0"/>
-              <a:t>General structure shall be enforced using JSON which is a common way to get structured output from a LLM.</a:t>
-            </a:r>
-          </a:p>
-          <a:p>
-            <a:pPr marL="0" marR="0" lvl="0" indent="0" algn="l" defTabSz="914400" rtl="0" eaLnBrk="1" fontAlgn="auto" latinLnBrk="0" hangingPunct="1">
-              <a:lnSpc>
-                <a:spcPct val="100000"/>
-              </a:lnSpc>
-              <a:spcBef>
-                <a:spcPts val="0"/>
-              </a:spcBef>
-              <a:spcAft>
-                <a:spcPts val="0"/>
-              </a:spcAft>
-              <a:buClrTx/>
-              <a:buSzTx/>
-              <a:buFontTx/>
-              <a:buNone/>
-              <a:tabLst/>
-              <a:defRPr/>
-            </a:pPr>
-            <a:r>
-              <a:rPr lang="en-GB" sz="1200" dirty="0">
-                <a:latin typeface="Consolas" panose="020B0609020204030204" pitchFamily="49" charset="0"/>
-              </a:rPr>
-              <a:t>Requirement, test objective, preconditions, test steps, expected result </a:t>
-            </a:r>
-            <a:endParaRPr lang="en-GB" dirty="0">
-              <a:latin typeface="Consolas" panose="020B0609020204030204" pitchFamily="49" charset="0"/>
-            </a:endParaRPr>
-          </a:p>
-          <a:p>
-            <a:pPr marL="0" marR="0" lvl="0" indent="0" algn="l" defTabSz="914400" rtl="0" eaLnBrk="1" fontAlgn="auto" latinLnBrk="0" hangingPunct="1">
-              <a:lnSpc>
-                <a:spcPct val="100000"/>
-              </a:lnSpc>
-              <a:spcBef>
-                <a:spcPts val="0"/>
-              </a:spcBef>
-              <a:spcAft>
-                <a:spcPts val="0"/>
-              </a:spcAft>
-              <a:buClrTx/>
-              <a:buSzTx/>
-              <a:buFontTx/>
-              <a:buNone/>
-              <a:tabLst/>
-              <a:defRPr/>
-            </a:pPr>
-            <a:endParaRPr lang="en-GB" dirty="0"/>
-          </a:p>
-          <a:p>
-            <a:pPr marL="0" marR="0" lvl="0" indent="0" algn="l" defTabSz="914400" rtl="0" eaLnBrk="1" fontAlgn="auto" latinLnBrk="0" hangingPunct="1">
-              <a:lnSpc>
-                <a:spcPct val="100000"/>
-              </a:lnSpc>
-              <a:spcBef>
-                <a:spcPts val="0"/>
-              </a:spcBef>
-              <a:spcAft>
-                <a:spcPts val="0"/>
-              </a:spcAft>
-              <a:buClrTx/>
-              <a:buSzTx/>
-              <a:buFontTx/>
-              <a:buNone/>
-              <a:tabLst/>
-              <a:defRPr/>
-            </a:pPr>
-            <a:r>
-              <a:rPr lang="en-GB" dirty="0"/>
-              <a:t>Using prompt engineering techniques to generate testcase for each requirement.</a:t>
-            </a:r>
-          </a:p>
-          <a:p>
-            <a:pPr marL="0" marR="0" lvl="0" indent="0" algn="l" defTabSz="914400" rtl="0" eaLnBrk="1" fontAlgn="auto" latinLnBrk="0" hangingPunct="1">
-              <a:lnSpc>
-                <a:spcPct val="100000"/>
-              </a:lnSpc>
-              <a:spcBef>
-                <a:spcPts val="0"/>
-              </a:spcBef>
-              <a:spcAft>
-                <a:spcPts val="0"/>
-              </a:spcAft>
-              <a:buClrTx/>
-              <a:buSzTx/>
-              <a:buFontTx/>
-              <a:buNone/>
-              <a:tabLst/>
-              <a:defRPr/>
-            </a:pPr>
-            <a:r>
-              <a:rPr lang="en-GB" dirty="0"/>
-              <a:t>Simple validation structure for each component for a first quality estimate of model and prompt.</a:t>
-            </a:r>
-          </a:p>
-          <a:p>
-            <a:pPr marL="0" marR="0" lvl="0" indent="0" algn="l" defTabSz="914400" rtl="0" eaLnBrk="1" fontAlgn="auto" latinLnBrk="0" hangingPunct="1">
-              <a:lnSpc>
-                <a:spcPct val="100000"/>
-              </a:lnSpc>
-              <a:spcBef>
-                <a:spcPts val="0"/>
-              </a:spcBef>
-              <a:spcAft>
-                <a:spcPts val="0"/>
-              </a:spcAft>
-              <a:buClrTx/>
-              <a:buSzTx/>
-              <a:buFontTx/>
-              <a:buNone/>
-              <a:tabLst/>
-              <a:defRPr/>
-            </a:pPr>
-            <a:endParaRPr lang="en-GB" dirty="0"/>
-          </a:p>
-          <a:p>
-            <a:pPr marL="0" marR="0" lvl="0" indent="0" algn="l" defTabSz="914400" rtl="0" eaLnBrk="1" fontAlgn="auto" latinLnBrk="0" hangingPunct="1">
-              <a:lnSpc>
-                <a:spcPct val="100000"/>
-              </a:lnSpc>
-              <a:spcBef>
-                <a:spcPts val="0"/>
-              </a:spcBef>
-              <a:spcAft>
-                <a:spcPts val="0"/>
-              </a:spcAft>
-              <a:buClrTx/>
-              <a:buSzTx/>
-              <a:buFontTx/>
-              <a:buNone/>
-              <a:tabLst/>
-              <a:defRPr/>
-            </a:pPr>
-            <a:r>
-              <a:rPr lang="en-GB" dirty="0"/>
-              <a:t>Describe few rules….</a:t>
-            </a:r>
-          </a:p>
-          <a:p>
-            <a:pPr marL="0" marR="0" lvl="0" indent="0" algn="l" defTabSz="914400" rtl="0" eaLnBrk="1" fontAlgn="auto" latinLnBrk="0" hangingPunct="1">
-              <a:lnSpc>
-                <a:spcPct val="100000"/>
-              </a:lnSpc>
-              <a:spcBef>
-                <a:spcPts val="0"/>
-              </a:spcBef>
-              <a:spcAft>
-                <a:spcPts val="0"/>
-              </a:spcAft>
-              <a:buClrTx/>
-              <a:buSzTx/>
-              <a:buFontTx/>
-              <a:buNone/>
-              <a:tabLst/>
-              <a:defRPr/>
-            </a:pPr>
-            <a:endParaRPr lang="en-GB" dirty="0"/>
-          </a:p>
-          <a:p>
-            <a:pPr marL="0" marR="0" lvl="0" indent="0" algn="l" defTabSz="914400" rtl="0" eaLnBrk="1" fontAlgn="auto" latinLnBrk="0" hangingPunct="1">
-              <a:lnSpc>
-                <a:spcPct val="100000"/>
-              </a:lnSpc>
-              <a:spcBef>
-                <a:spcPts val="0"/>
-              </a:spcBef>
-              <a:spcAft>
-                <a:spcPts val="0"/>
-              </a:spcAft>
-              <a:buClrTx/>
-              <a:buSzTx/>
-              <a:buFontTx/>
-              <a:buNone/>
-              <a:tabLst/>
-              <a:defRPr/>
-            </a:pPr>
-            <a:r>
-              <a:rPr lang="en-GB" dirty="0"/>
-              <a:t>As a last step human verification </a:t>
-            </a:r>
-          </a:p>
-          <a:p>
-            <a:endParaRPr lang="en-GB" dirty="0"/>
-          </a:p>
-          <a:p>
-            <a:pPr marL="0" marR="0" lvl="0" indent="0" algn="l" defTabSz="914400" rtl="0" eaLnBrk="1" fontAlgn="auto" latinLnBrk="0" hangingPunct="1">
-              <a:lnSpc>
-                <a:spcPct val="100000"/>
-              </a:lnSpc>
-              <a:spcBef>
-                <a:spcPts val="0"/>
-              </a:spcBef>
-              <a:spcAft>
-                <a:spcPts val="0"/>
-              </a:spcAft>
-              <a:buClrTx/>
-              <a:buSzTx/>
-              <a:buFontTx/>
-              <a:buNone/>
-              <a:tabLst/>
-              <a:defRPr/>
-            </a:pPr>
-            <a:r>
-              <a:rPr lang="en-GB" dirty="0"/>
-              <a:t>Implementation:</a:t>
+              <a:t>how detailed requirements are defined – usually using natural language</a:t>
             </a:r>
           </a:p>
           <a:p>
@@ -1351,51 +890,95 @@
             </a:pPr>
             <a:r>
               <a:rPr lang="en-GB" dirty="0"/>
-              <a:t>OLLAMA API, focus on local models?, …</a:t>
-            </a:r>
-          </a:p>
-          <a:p>
-            <a:pPr marL="171450" marR="0" lvl="0" indent="-171450" algn="l" defTabSz="914400" rtl="0" eaLnBrk="1" fontAlgn="auto" latinLnBrk="0" hangingPunct="1">
-              <a:lnSpc>
-                <a:spcPct val="100000"/>
-              </a:lnSpc>
-              <a:spcBef>
-                <a:spcPts val="0"/>
-              </a:spcBef>
-              <a:spcAft>
-                <a:spcPts val="0"/>
-              </a:spcAft>
-              <a:buClrTx/>
-              <a:buSzTx/>
+              <a:t>room for interpretation – possible conflicts, … but definition is another topic (verifying requirements for completeness, integrity, …. Is another story)</a:t>
+            </a:r>
+          </a:p>
+          <a:p>
+            <a:pPr marL="171450" indent="-171450">
               <a:buFontTx/>
               <a:buChar char="-"/>
-              <a:tabLst/>
-              <a:defRPr/>
+            </a:pPr>
+            <a:r>
+              <a:rPr lang="en-GB" dirty="0"/>
+              <a:t>requirements define what the system must to but not how.</a:t>
+            </a:r>
+          </a:p>
+          <a:p>
+            <a:pPr marL="171450" indent="-171450">
+              <a:buFontTx/>
+              <a:buChar char="-"/>
+            </a:pPr>
+            <a:r>
+              <a:rPr lang="en-GB" dirty="0"/>
+              <a:t>basic functionality of a system shall be tested through simple testcases that relate to at least one requirement.</a:t>
+            </a:r>
+          </a:p>
+          <a:p>
+            <a:endParaRPr lang="en-GB" dirty="0"/>
+          </a:p>
+          <a:p>
+            <a:r>
+              <a:rPr lang="en-GB" dirty="0"/>
+              <a:t>Requirements usually short precise definition of expected behaviour.</a:t>
+            </a:r>
+          </a:p>
+          <a:p>
+            <a:r>
+              <a:rPr lang="en-GB" dirty="0"/>
+              <a:t>I am interested in how capable LLM’s are in generating structured test case description out of natural language requirements.</a:t>
+            </a:r>
+          </a:p>
+          <a:p>
+            <a:r>
+              <a:rPr lang="en-GB" dirty="0"/>
+              <a:t>Especially in techincal domains.</a:t>
+            </a:r>
+          </a:p>
+          <a:p>
+            <a:r>
+              <a:rPr lang="en-GB" dirty="0"/>
+              <a:t>Idea that in the future the approach would be a semi automatic acceptance testing pipeline with human in the loop.</a:t>
+            </a:r>
+          </a:p>
+          <a:p>
+            <a:endParaRPr lang="en-GB" dirty="0"/>
+          </a:p>
+          <a:p>
+            <a:r>
+              <a:rPr lang="en-GB" dirty="0"/>
+              <a:t>requirements -&gt; LLM -&gt; TC’s + Human verification as a first part of the pipeline</a:t>
+            </a:r>
+          </a:p>
+          <a:p>
+            <a:r>
+              <a:rPr lang="en-GB" dirty="0"/>
+              <a:t>-&gt; LLM -&gt; implementation human or machine + verification through gernerated TC + Human verification</a:t>
+            </a:r>
+          </a:p>
+          <a:p>
+            <a:endParaRPr lang="en-GB" dirty="0"/>
+          </a:p>
+          <a:p>
+            <a:r>
+              <a:rPr lang="en-GB" dirty="0"/>
+              <a:t>First we need to get an impression of how capable the models are to understand the requirements.</a:t>
+            </a:r>
+            <a:endParaRPr lang="en-AT" dirty="0"/>
+          </a:p>
+          <a:p>
+            <a:endParaRPr lang="en-GB" dirty="0"/>
+          </a:p>
+          <a:p>
+            <a:endParaRPr lang="en-GB" dirty="0"/>
+          </a:p>
+          <a:p>
+            <a:pPr marL="0" indent="0">
+              <a:buNone/>
             </a:pPr>
             <a:endParaRPr lang="en-GB" dirty="0"/>
           </a:p>
           <a:p>
-            <a:pPr marL="0" marR="0" lvl="0" indent="0" algn="l" defTabSz="914400" rtl="0" eaLnBrk="1" fontAlgn="auto" latinLnBrk="0" hangingPunct="1">
-              <a:lnSpc>
-                <a:spcPct val="100000"/>
-              </a:lnSpc>
-              <a:spcBef>
-                <a:spcPts val="0"/>
-              </a:spcBef>
-              <a:spcAft>
-                <a:spcPts val="0"/>
-              </a:spcAft>
-              <a:buClrTx/>
-              <a:buSzTx/>
-              <a:buFontTx/>
-              <a:buNone/>
-              <a:tabLst/>
-              <a:defRPr/>
-            </a:pPr>
-            <a:endParaRPr lang="en-GB" dirty="0"/>
-          </a:p>
-          <a:p>
-            <a:endParaRPr lang="en-GB" dirty="0"/>
+            <a:endParaRPr lang="en-AT" dirty="0"/>
           </a:p>
         </p:txBody>
       </p:sp>
@@ -1416,7 +999,7 @@
           <a:p>
             <a:fld id="{75C8DF60-03EB-41BF-AD08-E11AFAEB47A5}" type="slidenum">
               <a:rPr lang="en-AT" smtClean="0"/>
-              <a:t>5</a:t>
+              <a:t>4</a:t>
             </a:fld>
             <a:endParaRPr lang="en-AT"/>
           </a:p>
@@ -1425,7 +1008,7 @@
     </p:spTree>
     <p:extLst>
       <p:ext uri="{BB962C8B-B14F-4D97-AF65-F5344CB8AC3E}">
-        <p14:creationId xmlns:p14="http://schemas.microsoft.com/office/powerpoint/2010/main" val="2692396763"/>
+        <p14:creationId xmlns:p14="http://schemas.microsoft.com/office/powerpoint/2010/main" val="3541748672"/>
       </p:ext>
     </p:extLst>
   </p:cSld>
@@ -1479,6 +1062,560 @@
           <a:bodyPr/>
           <a:lstStyle/>
           <a:p>
+            <a:pPr marL="0" marR="0" lvl="0" indent="0" algn="l" defTabSz="914400" rtl="0" eaLnBrk="1" fontAlgn="auto" latinLnBrk="0" hangingPunct="1">
+              <a:lnSpc>
+                <a:spcPct val="100000"/>
+              </a:lnSpc>
+              <a:spcBef>
+                <a:spcPts val="0"/>
+              </a:spcBef>
+              <a:spcAft>
+                <a:spcPts val="0"/>
+              </a:spcAft>
+              <a:buClrTx/>
+              <a:buSzTx/>
+              <a:buFontTx/>
+              <a:buNone/>
+              <a:tabLst/>
+              <a:defRPr/>
+            </a:pPr>
+            <a:r>
+              <a:rPr lang="en-GB" dirty="0"/>
+              <a:t>As an experimental setup I first thought about the evaluation procedure.</a:t>
+            </a:r>
+          </a:p>
+          <a:p>
+            <a:pPr marL="0" marR="0" lvl="0" indent="0" algn="l" defTabSz="914400" rtl="0" eaLnBrk="1" fontAlgn="auto" latinLnBrk="0" hangingPunct="1">
+              <a:lnSpc>
+                <a:spcPct val="100000"/>
+              </a:lnSpc>
+              <a:spcBef>
+                <a:spcPts val="0"/>
+              </a:spcBef>
+              <a:spcAft>
+                <a:spcPts val="0"/>
+              </a:spcAft>
+              <a:buClrTx/>
+              <a:buSzTx/>
+              <a:buFontTx/>
+              <a:buNone/>
+              <a:tabLst/>
+              <a:defRPr/>
+            </a:pPr>
+            <a:r>
+              <a:rPr lang="en-GB" dirty="0"/>
+              <a:t>As the difficulty is not to generate output, but to evaluate the quality of the output</a:t>
+            </a:r>
+          </a:p>
+          <a:p>
+            <a:pPr marL="0" marR="0" lvl="0" indent="0" algn="l" defTabSz="914400" rtl="0" eaLnBrk="1" fontAlgn="auto" latinLnBrk="0" hangingPunct="1">
+              <a:lnSpc>
+                <a:spcPct val="100000"/>
+              </a:lnSpc>
+              <a:spcBef>
+                <a:spcPts val="0"/>
+              </a:spcBef>
+              <a:spcAft>
+                <a:spcPts val="0"/>
+              </a:spcAft>
+              <a:buClrTx/>
+              <a:buSzTx/>
+              <a:buFontTx/>
+              <a:buNone/>
+              <a:tabLst/>
+              <a:defRPr/>
+            </a:pPr>
+            <a:r>
+              <a:rPr lang="en-GB" dirty="0"/>
+              <a:t>Therefore I created a framework for structured test descriptions.</a:t>
+            </a:r>
+          </a:p>
+          <a:p>
+            <a:pPr marL="0" marR="0" lvl="0" indent="0" algn="l" defTabSz="914400" rtl="0" eaLnBrk="1" fontAlgn="auto" latinLnBrk="0" hangingPunct="1">
+              <a:lnSpc>
+                <a:spcPct val="100000"/>
+              </a:lnSpc>
+              <a:spcBef>
+                <a:spcPts val="0"/>
+              </a:spcBef>
+              <a:spcAft>
+                <a:spcPts val="0"/>
+              </a:spcAft>
+              <a:buClrTx/>
+              <a:buSzTx/>
+              <a:buFontTx/>
+              <a:buNone/>
+              <a:tabLst/>
+              <a:defRPr/>
+            </a:pPr>
+            <a:endParaRPr lang="en-GB" dirty="0"/>
+          </a:p>
+          <a:p>
+            <a:pPr marL="0" marR="0" lvl="0" indent="0" algn="l" defTabSz="914400" rtl="0" eaLnBrk="1" fontAlgn="auto" latinLnBrk="0" hangingPunct="1">
+              <a:lnSpc>
+                <a:spcPct val="100000"/>
+              </a:lnSpc>
+              <a:spcBef>
+                <a:spcPts val="0"/>
+              </a:spcBef>
+              <a:spcAft>
+                <a:spcPts val="0"/>
+              </a:spcAft>
+              <a:buClrTx/>
+              <a:buSzTx/>
+              <a:buFontTx/>
+              <a:buNone/>
+              <a:tabLst/>
+              <a:defRPr/>
+            </a:pPr>
+            <a:r>
+              <a:rPr lang="en-GB" dirty="0"/>
+              <a:t>General structure shall be enforced using JSON which is a common way to get structured output from a LLM -&gt; this already introduces a kind of directional stimulus.</a:t>
+            </a:r>
+          </a:p>
+          <a:p>
+            <a:pPr marL="0" marR="0" lvl="0" indent="0" algn="l" defTabSz="914400" rtl="0" eaLnBrk="1" fontAlgn="auto" latinLnBrk="0" hangingPunct="1">
+              <a:lnSpc>
+                <a:spcPct val="100000"/>
+              </a:lnSpc>
+              <a:spcBef>
+                <a:spcPts val="0"/>
+              </a:spcBef>
+              <a:spcAft>
+                <a:spcPts val="0"/>
+              </a:spcAft>
+              <a:buClrTx/>
+              <a:buSzTx/>
+              <a:buFontTx/>
+              <a:buNone/>
+              <a:tabLst/>
+              <a:defRPr/>
+            </a:pPr>
+            <a:r>
+              <a:rPr lang="en-GB" sz="1200" dirty="0">
+                <a:latin typeface="Consolas" panose="020B0609020204030204" pitchFamily="49" charset="0"/>
+              </a:rPr>
+              <a:t>Requirement, test objective, preconditions, test steps, expected result </a:t>
+            </a:r>
+            <a:endParaRPr lang="en-GB" dirty="0">
+              <a:latin typeface="Consolas" panose="020B0609020204030204" pitchFamily="49" charset="0"/>
+            </a:endParaRPr>
+          </a:p>
+          <a:p>
+            <a:pPr marL="0" marR="0" lvl="0" indent="0" algn="l" defTabSz="914400" rtl="0" eaLnBrk="1" fontAlgn="auto" latinLnBrk="0" hangingPunct="1">
+              <a:lnSpc>
+                <a:spcPct val="100000"/>
+              </a:lnSpc>
+              <a:spcBef>
+                <a:spcPts val="0"/>
+              </a:spcBef>
+              <a:spcAft>
+                <a:spcPts val="0"/>
+              </a:spcAft>
+              <a:buClrTx/>
+              <a:buSzTx/>
+              <a:buFontTx/>
+              <a:buNone/>
+              <a:tabLst/>
+              <a:defRPr/>
+            </a:pPr>
+            <a:endParaRPr lang="en-GB" dirty="0"/>
+          </a:p>
+          <a:p>
+            <a:pPr marL="0" marR="0" lvl="0" indent="0" algn="l" defTabSz="914400" rtl="0" eaLnBrk="1" fontAlgn="auto" latinLnBrk="0" hangingPunct="1">
+              <a:lnSpc>
+                <a:spcPct val="100000"/>
+              </a:lnSpc>
+              <a:spcBef>
+                <a:spcPts val="0"/>
+              </a:spcBef>
+              <a:spcAft>
+                <a:spcPts val="0"/>
+              </a:spcAft>
+              <a:buClrTx/>
+              <a:buSzTx/>
+              <a:buFontTx/>
+              <a:buNone/>
+              <a:tabLst/>
+              <a:defRPr/>
+            </a:pPr>
+            <a:r>
+              <a:rPr lang="en-GB" dirty="0"/>
+              <a:t>Using prompt engineering techniques to generate testcase for each requirement.</a:t>
+            </a:r>
+          </a:p>
+          <a:p>
+            <a:pPr marL="0" marR="0" lvl="0" indent="0" algn="l" defTabSz="914400" rtl="0" eaLnBrk="1" fontAlgn="auto" latinLnBrk="0" hangingPunct="1">
+              <a:lnSpc>
+                <a:spcPct val="100000"/>
+              </a:lnSpc>
+              <a:spcBef>
+                <a:spcPts val="0"/>
+              </a:spcBef>
+              <a:spcAft>
+                <a:spcPts val="0"/>
+              </a:spcAft>
+              <a:buClrTx/>
+              <a:buSzTx/>
+              <a:buFontTx/>
+              <a:buNone/>
+              <a:tabLst/>
+              <a:defRPr/>
+            </a:pPr>
+            <a:r>
+              <a:rPr lang="en-GB" dirty="0"/>
+              <a:t>Implement validation structure for each component of the test description for a first quality estimate of model and prompt.</a:t>
+            </a:r>
+          </a:p>
+          <a:p>
+            <a:pPr marL="0" marR="0" lvl="0" indent="0" algn="l" defTabSz="914400" rtl="0" eaLnBrk="1" fontAlgn="auto" latinLnBrk="0" hangingPunct="1">
+              <a:lnSpc>
+                <a:spcPct val="100000"/>
+              </a:lnSpc>
+              <a:spcBef>
+                <a:spcPts val="0"/>
+              </a:spcBef>
+              <a:spcAft>
+                <a:spcPts val="0"/>
+              </a:spcAft>
+              <a:buClrTx/>
+              <a:buSzTx/>
+              <a:buFontTx/>
+              <a:buNone/>
+              <a:tabLst/>
+              <a:defRPr/>
+            </a:pPr>
+            <a:endParaRPr lang="en-GB" dirty="0"/>
+          </a:p>
+          <a:p>
+            <a:pPr marL="0" marR="0" lvl="0" indent="0" algn="l" defTabSz="914400" rtl="0" eaLnBrk="1" fontAlgn="auto" latinLnBrk="0" hangingPunct="1">
+              <a:lnSpc>
+                <a:spcPct val="100000"/>
+              </a:lnSpc>
+              <a:spcBef>
+                <a:spcPts val="0"/>
+              </a:spcBef>
+              <a:spcAft>
+                <a:spcPts val="0"/>
+              </a:spcAft>
+              <a:buClrTx/>
+              <a:buSzTx/>
+              <a:buFontTx/>
+              <a:buNone/>
+              <a:tabLst/>
+              <a:defRPr/>
+            </a:pPr>
+            <a:r>
+              <a:rPr lang="en-GB" dirty="0"/>
+              <a:t>Requirement -&gt; high cosine similarity with original</a:t>
+            </a:r>
+          </a:p>
+          <a:p>
+            <a:pPr marL="0" marR="0" lvl="0" indent="0" algn="l" defTabSz="914400" rtl="0" eaLnBrk="1" fontAlgn="auto" latinLnBrk="0" hangingPunct="1">
+              <a:lnSpc>
+                <a:spcPct val="100000"/>
+              </a:lnSpc>
+              <a:spcBef>
+                <a:spcPts val="0"/>
+              </a:spcBef>
+              <a:spcAft>
+                <a:spcPts val="0"/>
+              </a:spcAft>
+              <a:buClrTx/>
+              <a:buSzTx/>
+              <a:buFontTx/>
+              <a:buNone/>
+              <a:tabLst/>
+              <a:defRPr/>
+            </a:pPr>
+            <a:r>
+              <a:rPr lang="en-GB" dirty="0"/>
+              <a:t>Use spacy pos tagging to verify expected field characteristics</a:t>
+            </a:r>
+          </a:p>
+          <a:p>
+            <a:pPr marL="0" marR="0" lvl="0" indent="0" algn="l" defTabSz="914400" rtl="0" eaLnBrk="1" fontAlgn="auto" latinLnBrk="0" hangingPunct="1">
+              <a:lnSpc>
+                <a:spcPct val="100000"/>
+              </a:lnSpc>
+              <a:spcBef>
+                <a:spcPts val="0"/>
+              </a:spcBef>
+              <a:spcAft>
+                <a:spcPts val="0"/>
+              </a:spcAft>
+              <a:buClrTx/>
+              <a:buSzTx/>
+              <a:buFontTx/>
+              <a:buNone/>
+              <a:tabLst/>
+              <a:defRPr/>
+            </a:pPr>
+            <a:r>
+              <a:rPr lang="en-GB" dirty="0"/>
+              <a:t>shall be present tense</a:t>
+            </a:r>
+          </a:p>
+          <a:p>
+            <a:pPr marL="0" marR="0" lvl="0" indent="0" algn="l" defTabSz="914400" rtl="0" eaLnBrk="1" fontAlgn="auto" latinLnBrk="0" hangingPunct="1">
+              <a:lnSpc>
+                <a:spcPct val="100000"/>
+              </a:lnSpc>
+              <a:spcBef>
+                <a:spcPts val="0"/>
+              </a:spcBef>
+              <a:spcAft>
+                <a:spcPts val="0"/>
+              </a:spcAft>
+              <a:buClrTx/>
+              <a:buSzTx/>
+              <a:buFontTx/>
+              <a:buNone/>
+              <a:tabLst/>
+              <a:defRPr/>
+            </a:pPr>
+            <a:r>
+              <a:rPr lang="en-GB" dirty="0"/>
+              <a:t>testObjective -&gt; describes the goal shall start with a verb</a:t>
+            </a:r>
+          </a:p>
+          <a:p>
+            <a:pPr marL="0" marR="0" lvl="0" indent="0" algn="l" defTabSz="914400" rtl="0" eaLnBrk="1" fontAlgn="auto" latinLnBrk="0" hangingPunct="1">
+              <a:lnSpc>
+                <a:spcPct val="100000"/>
+              </a:lnSpc>
+              <a:spcBef>
+                <a:spcPts val="0"/>
+              </a:spcBef>
+              <a:spcAft>
+                <a:spcPts val="0"/>
+              </a:spcAft>
+              <a:buClrTx/>
+              <a:buSzTx/>
+              <a:buFontTx/>
+              <a:buNone/>
+              <a:tabLst/>
+              <a:defRPr/>
+            </a:pPr>
+            <a:r>
+              <a:rPr lang="en-GB" dirty="0"/>
+              <a:t>preconditions -&gt; describes a state</a:t>
+            </a:r>
+          </a:p>
+          <a:p>
+            <a:pPr marL="0" marR="0" lvl="0" indent="0" algn="l" defTabSz="914400" rtl="0" eaLnBrk="1" fontAlgn="auto" latinLnBrk="0" hangingPunct="1">
+              <a:lnSpc>
+                <a:spcPct val="100000"/>
+              </a:lnSpc>
+              <a:spcBef>
+                <a:spcPts val="0"/>
+              </a:spcBef>
+              <a:spcAft>
+                <a:spcPts val="0"/>
+              </a:spcAft>
+              <a:buClrTx/>
+              <a:buSzTx/>
+              <a:buFontTx/>
+              <a:buNone/>
+              <a:tabLst/>
+              <a:defRPr/>
+            </a:pPr>
+            <a:r>
+              <a:rPr lang="en-GB" dirty="0"/>
+              <a:t>testSteps -&gt; generic check for list of sentences</a:t>
+            </a:r>
+          </a:p>
+          <a:p>
+            <a:pPr marL="0" marR="0" lvl="0" indent="0" algn="l" defTabSz="914400" rtl="0" eaLnBrk="1" fontAlgn="auto" latinLnBrk="0" hangingPunct="1">
+              <a:lnSpc>
+                <a:spcPct val="100000"/>
+              </a:lnSpc>
+              <a:spcBef>
+                <a:spcPts val="0"/>
+              </a:spcBef>
+              <a:spcAft>
+                <a:spcPts val="0"/>
+              </a:spcAft>
+              <a:buClrTx/>
+              <a:buSzTx/>
+              <a:buFontTx/>
+              <a:buNone/>
+              <a:tabLst/>
+              <a:defRPr/>
+            </a:pPr>
+            <a:r>
+              <a:rPr lang="en-GB" dirty="0"/>
+              <a:t>Expected results -&gt;</a:t>
+            </a:r>
+          </a:p>
+          <a:p>
+            <a:pPr marL="0" marR="0" lvl="0" indent="0" algn="l" defTabSz="914400" rtl="0" eaLnBrk="1" fontAlgn="auto" latinLnBrk="0" hangingPunct="1">
+              <a:lnSpc>
+                <a:spcPct val="100000"/>
+              </a:lnSpc>
+              <a:spcBef>
+                <a:spcPts val="0"/>
+              </a:spcBef>
+              <a:spcAft>
+                <a:spcPts val="0"/>
+              </a:spcAft>
+              <a:buClrTx/>
+              <a:buSzTx/>
+              <a:buFontTx/>
+              <a:buNone/>
+              <a:tabLst/>
+              <a:defRPr/>
+            </a:pPr>
+            <a:endParaRPr lang="en-GB" dirty="0"/>
+          </a:p>
+          <a:p>
+            <a:pPr marL="0" marR="0" lvl="0" indent="0" algn="l" defTabSz="914400" rtl="0" eaLnBrk="1" fontAlgn="auto" latinLnBrk="0" hangingPunct="1">
+              <a:lnSpc>
+                <a:spcPct val="100000"/>
+              </a:lnSpc>
+              <a:spcBef>
+                <a:spcPts val="0"/>
+              </a:spcBef>
+              <a:spcAft>
+                <a:spcPts val="0"/>
+              </a:spcAft>
+              <a:buClrTx/>
+              <a:buSzTx/>
+              <a:buFontTx/>
+              <a:buNone/>
+              <a:tabLst/>
+              <a:defRPr/>
+            </a:pPr>
+            <a:r>
+              <a:rPr lang="en-GB" dirty="0"/>
+              <a:t>As a last step human verification.</a:t>
+            </a:r>
+          </a:p>
+          <a:p>
+            <a:pPr marL="0" marR="0" lvl="0" indent="0" algn="l" defTabSz="914400" rtl="0" eaLnBrk="1" fontAlgn="auto" latinLnBrk="0" hangingPunct="1">
+              <a:lnSpc>
+                <a:spcPct val="100000"/>
+              </a:lnSpc>
+              <a:spcBef>
+                <a:spcPts val="0"/>
+              </a:spcBef>
+              <a:spcAft>
+                <a:spcPts val="0"/>
+              </a:spcAft>
+              <a:buClrTx/>
+              <a:buSzTx/>
+              <a:buFontTx/>
+              <a:buNone/>
+              <a:tabLst/>
+              <a:defRPr/>
+            </a:pPr>
+            <a:endParaRPr lang="en-GB" dirty="0"/>
+          </a:p>
+          <a:p>
+            <a:pPr marL="0" marR="0" lvl="0" indent="0" algn="l" defTabSz="914400" rtl="0" eaLnBrk="1" fontAlgn="auto" latinLnBrk="0" hangingPunct="1">
+              <a:lnSpc>
+                <a:spcPct val="100000"/>
+              </a:lnSpc>
+              <a:spcBef>
+                <a:spcPts val="0"/>
+              </a:spcBef>
+              <a:spcAft>
+                <a:spcPts val="0"/>
+              </a:spcAft>
+              <a:buClrTx/>
+              <a:buSzTx/>
+              <a:buFontTx/>
+              <a:buNone/>
+              <a:tabLst/>
+              <a:defRPr/>
+            </a:pPr>
+            <a:endParaRPr lang="en-GB" dirty="0"/>
+          </a:p>
+          <a:p>
+            <a:endParaRPr lang="en-GB" dirty="0"/>
+          </a:p>
+        </p:txBody>
+      </p:sp>
+      <p:sp>
+        <p:nvSpPr>
+          <p:cNvPr id="4" name="Slide Number Placeholder 3"/>
+          <p:cNvSpPr>
+            <a:spLocks noGrp="1"/>
+          </p:cNvSpPr>
+          <p:nvPr>
+            <p:ph type="sldNum" sz="quarter" idx="5"/>
+          </p:nvPr>
+        </p:nvSpPr>
+        <p:spPr/>
+        <p:txBody>
+          <a:bodyPr/>
+          <a:lstStyle/>
+          <a:p>
+            <a:fld id="{75C8DF60-03EB-41BF-AD08-E11AFAEB47A5}" type="slidenum">
+              <a:rPr lang="en-AT" smtClean="0"/>
+              <a:t>5</a:t>
+            </a:fld>
+            <a:endParaRPr lang="en-AT"/>
+          </a:p>
+        </p:txBody>
+      </p:sp>
+    </p:spTree>
+    <p:extLst>
+      <p:ext uri="{BB962C8B-B14F-4D97-AF65-F5344CB8AC3E}">
+        <p14:creationId xmlns:p14="http://schemas.microsoft.com/office/powerpoint/2010/main" val="2692396763"/>
+      </p:ext>
+    </p:extLst>
+  </p:cSld>
+  <p:clrMapOvr>
+    <a:masterClrMapping/>
+  </p:clrMapOvr>
+</p:notes>
+</file>
+
+<file path=ppt/notesSlides/notesSlide5.xml><?xml version="1.0" encoding="utf-8"?>
+<p:notes xmlns:a="http://schemas.openxmlformats.org/drawingml/2006/main" xmlns:r="http://schemas.openxmlformats.org/officeDocument/2006/relationships" xmlns:p="http://schemas.openxmlformats.org/presentationml/2006/main">
+  <p:cSld>
+    <p:spTree>
+      <p:nvGrpSpPr>
+        <p:cNvPr id="1" name=""/>
+        <p:cNvGrpSpPr/>
+        <p:nvPr/>
+      </p:nvGrpSpPr>
+      <p:grpSpPr>
+        <a:xfrm>
+          <a:off x="0" y="0"/>
+          <a:ext cx="0" cy="0"/>
+          <a:chOff x="0" y="0"/>
+          <a:chExt cx="0" cy="0"/>
+        </a:xfrm>
+      </p:grpSpPr>
+      <p:sp>
+        <p:nvSpPr>
+          <p:cNvPr id="2" name="Slide Image Placeholder 1"/>
+          <p:cNvSpPr>
+            <a:spLocks noGrp="1" noRot="1" noChangeAspect="1"/>
+          </p:cNvSpPr>
+          <p:nvPr>
+            <p:ph type="sldImg"/>
+          </p:nvPr>
+        </p:nvSpPr>
+        <p:spPr/>
+      </p:sp>
+      <p:sp>
+        <p:nvSpPr>
+          <p:cNvPr id="3" name="Notes Placeholder 2"/>
+          <p:cNvSpPr>
+            <a:spLocks noGrp="1"/>
+          </p:cNvSpPr>
+          <p:nvPr>
+            <p:ph type="body" idx="1"/>
+          </p:nvPr>
+        </p:nvSpPr>
+        <p:spPr/>
+        <p:txBody>
+          <a:bodyPr/>
+          <a:lstStyle/>
+          <a:p>
             <a:r>
               <a:rPr lang="en-GB" dirty="0"/>
               <a:t>Domain specific application chosen:</a:t>
@@ -1637,6 +1774,94 @@
     <p:extLst>
       <p:ext uri="{BB962C8B-B14F-4D97-AF65-F5344CB8AC3E}">
         <p14:creationId xmlns:p14="http://schemas.microsoft.com/office/powerpoint/2010/main" val="3964314433"/>
+      </p:ext>
+    </p:extLst>
+  </p:cSld>
+  <p:clrMapOvr>
+    <a:masterClrMapping/>
+  </p:clrMapOvr>
+</p:notes>
+</file>
+
+<file path=ppt/notesSlides/notesSlide6.xml><?xml version="1.0" encoding="utf-8"?>
+<p:notes xmlns:a="http://schemas.openxmlformats.org/drawingml/2006/main" xmlns:r="http://schemas.openxmlformats.org/officeDocument/2006/relationships" xmlns:p="http://schemas.openxmlformats.org/presentationml/2006/main">
+  <p:cSld>
+    <p:spTree>
+      <p:nvGrpSpPr>
+        <p:cNvPr id="1" name=""/>
+        <p:cNvGrpSpPr/>
+        <p:nvPr/>
+      </p:nvGrpSpPr>
+      <p:grpSpPr>
+        <a:xfrm>
+          <a:off x="0" y="0"/>
+          <a:ext cx="0" cy="0"/>
+          <a:chOff x="0" y="0"/>
+          <a:chExt cx="0" cy="0"/>
+        </a:xfrm>
+      </p:grpSpPr>
+      <p:sp>
+        <p:nvSpPr>
+          <p:cNvPr id="2" name="Slide Image Placeholder 1"/>
+          <p:cNvSpPr>
+            <a:spLocks noGrp="1" noRot="1" noChangeAspect="1"/>
+          </p:cNvSpPr>
+          <p:nvPr>
+            <p:ph type="sldImg"/>
+          </p:nvPr>
+        </p:nvSpPr>
+        <p:spPr/>
+      </p:sp>
+      <p:sp>
+        <p:nvSpPr>
+          <p:cNvPr id="3" name="Notes Placeholder 2"/>
+          <p:cNvSpPr>
+            <a:spLocks noGrp="1"/>
+          </p:cNvSpPr>
+          <p:nvPr>
+            <p:ph type="body" idx="1"/>
+          </p:nvPr>
+        </p:nvSpPr>
+        <p:spPr/>
+        <p:txBody>
+          <a:bodyPr/>
+          <a:lstStyle/>
+          <a:p>
+            <a:r>
+              <a:rPr lang="en-GB" dirty="0"/>
+              <a:t>As a baseline Zero shot learning was used with directional stimulus </a:t>
+            </a:r>
+            <a:endParaRPr lang="en-AT" dirty="0"/>
+          </a:p>
+        </p:txBody>
+      </p:sp>
+      <p:sp>
+        <p:nvSpPr>
+          <p:cNvPr id="4" name="Slide Number Placeholder 3"/>
+          <p:cNvSpPr>
+            <a:spLocks noGrp="1"/>
+          </p:cNvSpPr>
+          <p:nvPr>
+            <p:ph type="sldNum" sz="quarter" idx="5"/>
+          </p:nvPr>
+        </p:nvSpPr>
+        <p:spPr/>
+        <p:txBody>
+          <a:bodyPr/>
+          <a:lstStyle/>
+          <a:p>
+            <a:fld id="{75C8DF60-03EB-41BF-AD08-E11AFAEB47A5}" type="slidenum">
+              <a:rPr lang="en-AT" smtClean="0"/>
+              <a:t>8</a:t>
+            </a:fld>
+            <a:endParaRPr lang="en-AT"/>
+          </a:p>
+        </p:txBody>
+      </p:sp>
+    </p:spTree>
+    <p:extLst>
+      <p:ext uri="{BB962C8B-B14F-4D97-AF65-F5344CB8AC3E}">
+        <p14:creationId xmlns:p14="http://schemas.microsoft.com/office/powerpoint/2010/main" val="3643168453"/>
       </p:ext>
     </p:extLst>
   </p:cSld>
@@ -1795,7 +2020,7 @@
           <a:p>
             <a:fld id="{CD0BFEE2-3EAA-4386-9A3C-82D92E479C9F}" type="datetimeFigureOut">
               <a:rPr lang="en-AT" smtClean="0"/>
-              <a:t>23/04/2025</a:t>
+              <a:t>29/04/2025</a:t>
             </a:fld>
             <a:endParaRPr lang="en-AT"/>
           </a:p>
@@ -1995,7 +2220,7 @@
           <a:p>
             <a:fld id="{CD0BFEE2-3EAA-4386-9A3C-82D92E479C9F}" type="datetimeFigureOut">
               <a:rPr lang="en-AT" smtClean="0"/>
-              <a:t>23/04/2025</a:t>
+              <a:t>29/04/2025</a:t>
             </a:fld>
             <a:endParaRPr lang="en-AT"/>
           </a:p>
@@ -2205,7 +2430,7 @@
           <a:p>
             <a:fld id="{CD0BFEE2-3EAA-4386-9A3C-82D92E479C9F}" type="datetimeFigureOut">
               <a:rPr lang="en-AT" smtClean="0"/>
-              <a:t>23/04/2025</a:t>
+              <a:t>29/04/2025</a:t>
             </a:fld>
             <a:endParaRPr lang="en-AT"/>
           </a:p>
@@ -2405,7 +2630,7 @@
           <a:p>
             <a:fld id="{CD0BFEE2-3EAA-4386-9A3C-82D92E479C9F}" type="datetimeFigureOut">
               <a:rPr lang="en-AT" smtClean="0"/>
-              <a:t>23/04/2025</a:t>
+              <a:t>29/04/2025</a:t>
             </a:fld>
             <a:endParaRPr lang="en-AT"/>
           </a:p>
@@ -2681,7 +2906,7 @@
           <a:p>
             <a:fld id="{CD0BFEE2-3EAA-4386-9A3C-82D92E479C9F}" type="datetimeFigureOut">
               <a:rPr lang="en-AT" smtClean="0"/>
-              <a:t>23/04/2025</a:t>
+              <a:t>29/04/2025</a:t>
             </a:fld>
             <a:endParaRPr lang="en-AT"/>
           </a:p>
@@ -2949,7 +3174,7 @@
           <a:p>
             <a:fld id="{CD0BFEE2-3EAA-4386-9A3C-82D92E479C9F}" type="datetimeFigureOut">
               <a:rPr lang="en-AT" smtClean="0"/>
-              <a:t>23/04/2025</a:t>
+              <a:t>29/04/2025</a:t>
             </a:fld>
             <a:endParaRPr lang="en-AT"/>
           </a:p>
@@ -3364,7 +3589,7 @@
           <a:p>
             <a:fld id="{CD0BFEE2-3EAA-4386-9A3C-82D92E479C9F}" type="datetimeFigureOut">
               <a:rPr lang="en-AT" smtClean="0"/>
-              <a:t>23/04/2025</a:t>
+              <a:t>29/04/2025</a:t>
             </a:fld>
             <a:endParaRPr lang="en-AT"/>
           </a:p>
@@ -3506,7 +3731,7 @@
           <a:p>
             <a:fld id="{CD0BFEE2-3EAA-4386-9A3C-82D92E479C9F}" type="datetimeFigureOut">
               <a:rPr lang="en-AT" smtClean="0"/>
-              <a:t>23/04/2025</a:t>
+              <a:t>29/04/2025</a:t>
             </a:fld>
             <a:endParaRPr lang="en-AT"/>
           </a:p>
@@ -3619,7 +3844,7 @@
           <a:p>
             <a:fld id="{CD0BFEE2-3EAA-4386-9A3C-82D92E479C9F}" type="datetimeFigureOut">
               <a:rPr lang="en-AT" smtClean="0"/>
-              <a:t>23/04/2025</a:t>
+              <a:t>29/04/2025</a:t>
             </a:fld>
             <a:endParaRPr lang="en-AT"/>
           </a:p>
@@ -3932,7 +4157,7 @@
           <a:p>
             <a:fld id="{CD0BFEE2-3EAA-4386-9A3C-82D92E479C9F}" type="datetimeFigureOut">
               <a:rPr lang="en-AT" smtClean="0"/>
-              <a:t>23/04/2025</a:t>
+              <a:t>29/04/2025</a:t>
             </a:fld>
             <a:endParaRPr lang="en-AT"/>
           </a:p>
@@ -4221,7 +4446,7 @@
           <a:p>
             <a:fld id="{CD0BFEE2-3EAA-4386-9A3C-82D92E479C9F}" type="datetimeFigureOut">
               <a:rPr lang="en-AT" smtClean="0"/>
-              <a:t>23/04/2025</a:t>
+              <a:t>29/04/2025</a:t>
             </a:fld>
             <a:endParaRPr lang="en-AT"/>
           </a:p>
@@ -4464,7 +4689,7 @@
           <a:p>
             <a:fld id="{CD0BFEE2-3EAA-4386-9A3C-82D92E479C9F}" type="datetimeFigureOut">
               <a:rPr lang="en-AT" smtClean="0"/>
-              <a:t>23/04/2025</a:t>
+              <a:t>29/04/2025</a:t>
             </a:fld>
             <a:endParaRPr lang="en-AT"/>
           </a:p>
@@ -5425,7 +5650,7 @@
           <a:lstStyle/>
           <a:p>
             <a:r>
-              <a:rPr lang="en-GB">
+              <a:rPr lang="en-GB" dirty="0">
                 <a:latin typeface="Consolas" panose="020B0609020204030204" pitchFamily="49" charset="0"/>
               </a:rPr>
               <a:t>Outline</a:t>
@@ -5588,35 +5813,6 @@
           </a:p>
         </p:txBody>
       </p:sp>
-      <p:pic>
-        <p:nvPicPr>
-          <p:cNvPr id="5" name="Content Placeholder 4">
-            <a:extLst>
-              <a:ext uri="{FF2B5EF4-FFF2-40B4-BE49-F238E27FC236}">
-                <a16:creationId xmlns:a16="http://schemas.microsoft.com/office/drawing/2014/main" id="{507F5BA2-E442-8313-EF43-48BB47D63721}"/>
-              </a:ext>
-            </a:extLst>
-          </p:cNvPr>
-          <p:cNvPicPr>
-            <a:picLocks noGrp="1" noChangeAspect="1"/>
-          </p:cNvPicPr>
-          <p:nvPr>
-            <p:ph idx="1"/>
-          </p:nvPr>
-        </p:nvPicPr>
-        <p:blipFill>
-          <a:blip r:embed="rId3"/>
-          <a:stretch>
-            <a:fillRect/>
-          </a:stretch>
-        </p:blipFill>
-        <p:spPr>
-          <a:xfrm>
-            <a:off x="8156366" y="1397427"/>
-            <a:ext cx="3400425" cy="2790825"/>
-          </a:xfrm>
-        </p:spPr>
-      </p:pic>
       <p:sp>
         <p:nvSpPr>
           <p:cNvPr id="13" name="TextBox 12">
@@ -5937,15 +6133,21 @@
           </a:lstStyle>
           <a:p>
             <a:r>
-              <a:rPr lang="en-GB" dirty="0">
+              <a:rPr lang="en-GB" sz="2400" dirty="0">
                 <a:latin typeface="Consolas" panose="020B0609020204030204" pitchFamily="49" charset="0"/>
               </a:rPr>
               <a:t>Quality assurance through testing</a:t>
             </a:r>
           </a:p>
           <a:p>
-            <a:r>
-              <a:rPr lang="en-GB" dirty="0">
+            <a:pPr lvl="1"/>
+            <a:endParaRPr lang="en-GB" sz="2000" dirty="0">
+              <a:latin typeface="Consolas" panose="020B0609020204030204" pitchFamily="49" charset="0"/>
+            </a:endParaRPr>
+          </a:p>
+          <a:p>
+            <a:r>
+              <a:rPr lang="en-GB" sz="2400" dirty="0">
                 <a:latin typeface="Consolas" panose="020B0609020204030204" pitchFamily="49" charset="0"/>
               </a:rPr>
               <a:t>Strategies</a:t>
@@ -5954,49 +6156,79 @@
           <a:p>
             <a:pPr lvl="1"/>
             <a:r>
-              <a:rPr lang="en-GB" dirty="0">
+              <a:rPr lang="en-GB" sz="2000" dirty="0">
                 <a:latin typeface="Consolas" panose="020B0609020204030204" pitchFamily="49" charset="0"/>
               </a:rPr>
               <a:t>Unit testing</a:t>
             </a:r>
+            <a:endParaRPr lang="en-GB" sz="1600" dirty="0">
+              <a:latin typeface="Consolas" panose="020B0609020204030204" pitchFamily="49" charset="0"/>
+            </a:endParaRPr>
+          </a:p>
+          <a:p>
+            <a:pPr lvl="1"/>
+            <a:r>
+              <a:rPr lang="en-GB" sz="2000" dirty="0">
+                <a:latin typeface="Consolas" panose="020B0609020204030204" pitchFamily="49" charset="0"/>
+              </a:rPr>
+              <a:t>Integration testing</a:t>
+            </a:r>
+          </a:p>
+          <a:p>
+            <a:pPr lvl="1"/>
+            <a:r>
+              <a:rPr lang="en-GB" sz="2000" dirty="0">
+                <a:latin typeface="Consolas" panose="020B0609020204030204" pitchFamily="49" charset="0"/>
+              </a:rPr>
+              <a:t>Acceptance/Validation testing</a:t>
+            </a:r>
+          </a:p>
+          <a:p>
+            <a:pPr lvl="1"/>
+            <a:r>
+              <a:rPr lang="en-GB" sz="2000" dirty="0">
+                <a:latin typeface="Consolas" panose="020B0609020204030204" pitchFamily="49" charset="0"/>
+              </a:rPr>
+              <a:t>System testing</a:t>
+            </a:r>
+            <a:endParaRPr lang="en-GB" dirty="0">
+              <a:latin typeface="Consolas" panose="020B0609020204030204" pitchFamily="49" charset="0"/>
+            </a:endParaRPr>
+          </a:p>
+          <a:p>
+            <a:pPr marL="0" indent="0">
+              <a:buNone/>
+            </a:pPr>
             <a:endParaRPr lang="en-GB" sz="1800" dirty="0">
               <a:latin typeface="Consolas" panose="020B0609020204030204" pitchFamily="49" charset="0"/>
             </a:endParaRPr>
           </a:p>
           <a:p>
-            <a:pPr lvl="1"/>
-            <a:r>
-              <a:rPr lang="en-GB" dirty="0">
+            <a:r>
+              <a:rPr lang="en-GB" sz="2000" dirty="0">
                 <a:latin typeface="Consolas" panose="020B0609020204030204" pitchFamily="49" charset="0"/>
               </a:rPr>
-              <a:t>Integration testing</a:t>
-            </a:r>
-          </a:p>
-          <a:p>
-            <a:pPr lvl="1"/>
-            <a:r>
-              <a:rPr lang="en-GB" dirty="0">
+              <a:t>Research on applying LLM’s for </a:t>
+            </a:r>
+            <a:br>
+              <a:rPr lang="en-GB" sz="2000" dirty="0">
                 <a:latin typeface="Consolas" panose="020B0609020204030204" pitchFamily="49" charset="0"/>
               </a:rPr>
-              <a:t>Acceptance/Validation testing</a:t>
-            </a:r>
-          </a:p>
-          <a:p>
-            <a:pPr lvl="1"/>
-            <a:r>
-              <a:rPr lang="en-GB" dirty="0">
+            </a:br>
+            <a:r>
+              <a:rPr lang="en-GB" sz="2000" dirty="0">
                 <a:latin typeface="Consolas" panose="020B0609020204030204" pitchFamily="49" charset="0"/>
               </a:rPr>
-              <a:t>System testing</a:t>
-            </a:r>
-          </a:p>
-          <a:p>
-            <a:r>
-              <a:rPr lang="en-GB" sz="1600" dirty="0">
-                <a:latin typeface="Consolas" panose="020B0609020204030204" pitchFamily="49" charset="0"/>
-              </a:rPr>
-              <a:t>Most of LLM research on System and Unit testing</a:t>
-            </a:r>
+              <a:t>different testing strategies:</a:t>
+            </a:r>
+          </a:p>
+          <a:p>
+            <a:pPr lvl="1"/>
+            <a:endParaRPr lang="en-GB" sz="1400" dirty="0">
+              <a:latin typeface="Consolas" panose="020B0609020204030204" pitchFamily="49" charset="0"/>
+            </a:endParaRPr>
+          </a:p>
+          <a:p>
             <a:endParaRPr lang="en-AT" sz="1600" dirty="0">
               <a:latin typeface="Consolas" panose="020B0609020204030204" pitchFamily="49" charset="0"/>
             </a:endParaRPr>
@@ -6018,15 +6250,15 @@
           <p:nvPr/>
         </p:nvPicPr>
         <p:blipFill>
-          <a:blip r:embed="rId4"/>
+          <a:blip r:embed="rId3"/>
           <a:stretch>
             <a:fillRect/>
           </a:stretch>
         </p:blipFill>
         <p:spPr>
           <a:xfrm>
-            <a:off x="7689954" y="4099721"/>
-            <a:ext cx="4055386" cy="2358033"/>
+            <a:off x="6608027" y="3340241"/>
+            <a:ext cx="5421955" cy="3152634"/>
           </a:xfrm>
           <a:prstGeom prst="rect">
             <a:avLst/>
@@ -6101,35 +6333,6 @@
           </a:p>
         </p:txBody>
       </p:sp>
-      <p:pic>
-        <p:nvPicPr>
-          <p:cNvPr id="7" name="Content Placeholder 4">
-            <a:extLst>
-              <a:ext uri="{FF2B5EF4-FFF2-40B4-BE49-F238E27FC236}">
-                <a16:creationId xmlns:a16="http://schemas.microsoft.com/office/drawing/2014/main" id="{24381BF6-875C-C6D7-0F8A-56A34AFA6222}"/>
-              </a:ext>
-            </a:extLst>
-          </p:cNvPr>
-          <p:cNvPicPr>
-            <a:picLocks noGrp="1" noChangeAspect="1"/>
-          </p:cNvPicPr>
-          <p:nvPr>
-            <p:ph idx="1"/>
-          </p:nvPr>
-        </p:nvPicPr>
-        <p:blipFill>
-          <a:blip r:embed="rId3"/>
-          <a:stretch>
-            <a:fillRect/>
-          </a:stretch>
-        </p:blipFill>
-        <p:spPr>
-          <a:xfrm>
-            <a:off x="8189279" y="1567203"/>
-            <a:ext cx="3400425" cy="2790825"/>
-          </a:xfrm>
-        </p:spPr>
-      </p:pic>
       <p:sp>
         <p:nvSpPr>
           <p:cNvPr id="4" name="Content Placeholder 2">
@@ -6347,7 +6550,7 @@
         </p:nvSpPr>
         <p:spPr>
           <a:xfrm>
-            <a:off x="800724" y="1850401"/>
+            <a:off x="756274" y="1888841"/>
             <a:ext cx="10515600" cy="4351338"/>
           </a:xfrm>
           <a:prstGeom prst="rect">
@@ -6524,40 +6727,53 @@
           </a:lstStyle>
           <a:p>
             <a:r>
-              <a:rPr lang="en-GB" dirty="0">
+              <a:rPr lang="en-GB" sz="2400" dirty="0">
                 <a:latin typeface="Consolas" panose="020B0609020204030204" pitchFamily="49" charset="0"/>
               </a:rPr>
-              <a:t>Ensuring project meets </a:t>
-            </a:r>
-            <a:br>
-              <a:rPr lang="en-GB" dirty="0">
+              <a:t>Are requirements fullfilled?</a:t>
+            </a:r>
+          </a:p>
+          <a:p>
+            <a:endParaRPr lang="en-GB" sz="2400" dirty="0">
+              <a:latin typeface="Consolas" panose="020B0609020204030204" pitchFamily="49" charset="0"/>
+            </a:endParaRPr>
+          </a:p>
+          <a:p>
+            <a:r>
+              <a:rPr lang="en-GB" sz="2400" dirty="0">
                 <a:latin typeface="Consolas" panose="020B0609020204030204" pitchFamily="49" charset="0"/>
               </a:rPr>
-            </a:br>
-            <a:r>
-              <a:rPr lang="en-GB" dirty="0">
+              <a:t>How capable are LLM’s in:</a:t>
+            </a:r>
+          </a:p>
+          <a:p>
+            <a:pPr lvl="1"/>
+            <a:endParaRPr lang="en-GB" sz="2000" dirty="0">
+              <a:latin typeface="Consolas" panose="020B0609020204030204" pitchFamily="49" charset="0"/>
+            </a:endParaRPr>
+          </a:p>
+          <a:p>
+            <a:pPr lvl="1"/>
+            <a:r>
+              <a:rPr lang="en-GB" sz="2000" dirty="0">
                 <a:latin typeface="Consolas" panose="020B0609020204030204" pitchFamily="49" charset="0"/>
               </a:rPr>
-              <a:t>base requirements</a:t>
-            </a:r>
-          </a:p>
-          <a:p>
-            <a:r>
-              <a:rPr lang="en-GB" dirty="0">
+              <a:t>Understanding requirements in technical domain?</a:t>
+            </a:r>
+          </a:p>
+          <a:p>
+            <a:pPr lvl="1"/>
+            <a:endParaRPr lang="en-GB" sz="2000" dirty="0">
+              <a:latin typeface="Consolas" panose="020B0609020204030204" pitchFamily="49" charset="0"/>
+            </a:endParaRPr>
+          </a:p>
+          <a:p>
+            <a:pPr lvl="1"/>
+            <a:r>
+              <a:rPr lang="en-GB" sz="2000" dirty="0">
                 <a:latin typeface="Consolas" panose="020B0609020204030204" pitchFamily="49" charset="0"/>
               </a:rPr>
-              <a:t>Requirements highly dependent on </a:t>
-            </a:r>
-            <a:br>
-              <a:rPr lang="en-GB" dirty="0">
-                <a:latin typeface="Consolas" panose="020B0609020204030204" pitchFamily="49" charset="0"/>
-              </a:rPr>
-            </a:br>
-            <a:r>
-              <a:rPr lang="en-GB" dirty="0">
-                <a:latin typeface="Consolas" panose="020B0609020204030204" pitchFamily="49" charset="0"/>
-              </a:rPr>
-              <a:t>domain and project leads</a:t>
+              <a:t>Deriving test descriptions from requirements?</a:t>
             </a:r>
           </a:p>
           <a:p>
@@ -6565,19 +6781,14 @@
               <a:latin typeface="Consolas" panose="020B0609020204030204" pitchFamily="49" charset="0"/>
             </a:endParaRPr>
           </a:p>
-          <a:p>
-            <a:endParaRPr lang="en-AT" dirty="0">
-              <a:latin typeface="Consolas" panose="020B0609020204030204" pitchFamily="49" charset="0"/>
-            </a:endParaRPr>
-          </a:p>
         </p:txBody>
       </p:sp>
       <p:pic>
         <p:nvPicPr>
-          <p:cNvPr id="9" name="Picture 8">
-            <a:extLst>
-              <a:ext uri="{FF2B5EF4-FFF2-40B4-BE49-F238E27FC236}">
-                <a16:creationId xmlns:a16="http://schemas.microsoft.com/office/drawing/2014/main" id="{65419378-99D6-E9AE-D153-C28579E57131}"/>
+          <p:cNvPr id="12" name="Picture 11" descr="A diagram of a software process&#10;&#10;AI-generated content may be incorrect.">
+            <a:extLst>
+              <a:ext uri="{FF2B5EF4-FFF2-40B4-BE49-F238E27FC236}">
+                <a16:creationId xmlns:a16="http://schemas.microsoft.com/office/drawing/2014/main" id="{8668134D-364E-A501-4C35-C07E89BAF2A6}"/>
               </a:ext>
             </a:extLst>
           </p:cNvPr>
@@ -6587,15 +6798,21 @@
           <p:nvPr/>
         </p:nvPicPr>
         <p:blipFill>
-          <a:blip r:embed="rId4"/>
+          <a:blip r:embed="rId3">
+            <a:extLst>
+              <a:ext uri="{28A0092B-C50C-407E-A947-70E740481C1C}">
+                <a14:useLocalDpi xmlns:a14="http://schemas.microsoft.com/office/drawing/2010/main" val="0"/>
+              </a:ext>
+            </a:extLst>
+          </a:blip>
           <a:stretch>
             <a:fillRect/>
           </a:stretch>
         </p:blipFill>
         <p:spPr>
           <a:xfrm>
-            <a:off x="1504950" y="5282309"/>
-            <a:ext cx="8296275" cy="685800"/>
+            <a:off x="8702072" y="1333834"/>
+            <a:ext cx="3173584" cy="5121565"/>
           </a:xfrm>
           <a:prstGeom prst="rect">
             <a:avLst/>
@@ -6681,13 +6898,18 @@
             <p:ph idx="1"/>
           </p:nvPr>
         </p:nvSpPr>
-        <p:spPr/>
+        <p:spPr>
+          <a:xfrm>
+            <a:off x="838200" y="1690688"/>
+            <a:ext cx="10515600" cy="4351338"/>
+          </a:xfrm>
+        </p:spPr>
         <p:txBody>
           <a:bodyPr/>
           <a:lstStyle/>
           <a:p>
             <a:r>
-              <a:rPr lang="en-GB" dirty="0">
+              <a:rPr lang="en-GB" sz="2400" dirty="0">
                 <a:latin typeface="Consolas" panose="020B0609020204030204" pitchFamily="49" charset="0"/>
               </a:rPr>
               <a:t>Evaluation Procedure</a:t>
@@ -6696,7 +6918,7 @@
           <a:p>
             <a:pPr lvl="1"/>
             <a:r>
-              <a:rPr lang="en-GB" dirty="0">
+              <a:rPr lang="en-GB" sz="2000" dirty="0">
                 <a:latin typeface="Consolas" panose="020B0609020204030204" pitchFamily="49" charset="0"/>
               </a:rPr>
               <a:t>Use prompt engineering techniques to generate testcases</a:t>
@@ -6705,16 +6927,16 @@
           <a:p>
             <a:pPr lvl="1"/>
             <a:r>
-              <a:rPr lang="en-GB" dirty="0">
+              <a:rPr lang="en-GB" sz="2000" dirty="0">
                 <a:latin typeface="Consolas" panose="020B0609020204030204" pitchFamily="49" charset="0"/>
               </a:rPr>
-              <a:t>Simple validation structure for initial quality estimate of model output + prompt</a:t>
+              <a:t>Validation structure for initial quality estimate of model output + prompt</a:t>
             </a:r>
           </a:p>
           <a:p>
             <a:pPr lvl="1"/>
             <a:r>
-              <a:rPr lang="en-GB" dirty="0">
+              <a:rPr lang="en-GB" sz="2000" dirty="0">
                 <a:latin typeface="Consolas" panose="020B0609020204030204" pitchFamily="49" charset="0"/>
               </a:rPr>
               <a:t>Basic Test Description structure shall be enforced</a:t>
@@ -6722,20 +6944,38 @@
           </a:p>
           <a:p>
             <a:pPr lvl="2"/>
-            <a:r>
-              <a:rPr lang="en-GB" sz="2000" dirty="0">
-                <a:latin typeface="Consolas" panose="020B0609020204030204" pitchFamily="49" charset="0"/>
-              </a:rPr>
-              <a:t>Requirement, test objective, preconditions, test steps, expected result </a:t>
-            </a:r>
-            <a:endParaRPr lang="en-GB" dirty="0">
+            <a:endParaRPr lang="en-GB" sz="1800" dirty="0">
               <a:latin typeface="Consolas" panose="020B0609020204030204" pitchFamily="49" charset="0"/>
             </a:endParaRPr>
           </a:p>
           <a:p>
+            <a:pPr lvl="2"/>
+            <a:endParaRPr lang="en-GB" sz="1800" dirty="0">
+              <a:latin typeface="Consolas" panose="020B0609020204030204" pitchFamily="49" charset="0"/>
+            </a:endParaRPr>
+          </a:p>
+          <a:p>
+            <a:pPr lvl="2"/>
+            <a:endParaRPr lang="en-GB" sz="1800" dirty="0">
+              <a:latin typeface="Consolas" panose="020B0609020204030204" pitchFamily="49" charset="0"/>
+            </a:endParaRPr>
+          </a:p>
+          <a:p>
+            <a:pPr lvl="2"/>
+            <a:endParaRPr lang="en-GB" sz="1800" dirty="0">
+              <a:latin typeface="Consolas" panose="020B0609020204030204" pitchFamily="49" charset="0"/>
+            </a:endParaRPr>
+          </a:p>
+          <a:p>
+            <a:pPr lvl="2"/>
+            <a:endParaRPr lang="en-GB" sz="1800" dirty="0">
+              <a:latin typeface="Consolas" panose="020B0609020204030204" pitchFamily="49" charset="0"/>
+            </a:endParaRPr>
+          </a:p>
+          <a:p>
             <a:pPr lvl="1"/>
             <a:r>
-              <a:rPr lang="en-GB" dirty="0">
+              <a:rPr lang="en-GB" sz="2000" dirty="0">
                 <a:latin typeface="Consolas" panose="020B0609020204030204" pitchFamily="49" charset="0"/>
               </a:rPr>
               <a:t>Human verification as final evaluation</a:t>
@@ -6749,6 +6989,36 @@
           </a:p>
         </p:txBody>
       </p:sp>
+      <p:pic>
+        <p:nvPicPr>
+          <p:cNvPr id="5" name="Picture 4">
+            <a:extLst>
+              <a:ext uri="{FF2B5EF4-FFF2-40B4-BE49-F238E27FC236}">
+                <a16:creationId xmlns:a16="http://schemas.microsoft.com/office/drawing/2014/main" id="{3E48E7C1-7749-EDCC-8F01-AEDE69A6F890}"/>
+              </a:ext>
+            </a:extLst>
+          </p:cNvPr>
+          <p:cNvPicPr>
+            <a:picLocks noChangeAspect="1"/>
+          </p:cNvPicPr>
+          <p:nvPr/>
+        </p:nvPicPr>
+        <p:blipFill>
+          <a:blip r:embed="rId3"/>
+          <a:stretch>
+            <a:fillRect/>
+          </a:stretch>
+        </p:blipFill>
+        <p:spPr>
+          <a:xfrm>
+            <a:off x="3476786" y="3429000"/>
+            <a:ext cx="2415107" cy="1434615"/>
+          </a:xfrm>
+          <a:prstGeom prst="rect">
+            <a:avLst/>
+          </a:prstGeom>
+        </p:spPr>
+      </p:pic>
     </p:spTree>
     <p:extLst>
       <p:ext uri="{BB962C8B-B14F-4D97-AF65-F5344CB8AC3E}">
@@ -7267,14 +7537,6 @@
                 <a:latin typeface="Consolas" panose="020B0609020204030204" pitchFamily="49" charset="0"/>
               </a:rPr>
               <a:t>Providing context</a:t>
-            </a:r>
-          </a:p>
-          <a:p>
-            <a:r>
-              <a:rPr lang="en-GB" dirty="0">
-                <a:latin typeface="Consolas" panose="020B0609020204030204" pitchFamily="49" charset="0"/>
-              </a:rPr>
-              <a:t>Multimodality</a:t>
             </a:r>
           </a:p>
           <a:p>

</xml_diff>